<commit_message>
Regenerate five verified public exemplar publication trees
</commit_message>
<xml_diff>
--- a/projects/templates/template_pitch_deck/output/pptx/template_template_pitch_long.pptx
+++ b/projects/templates/template_pitch_deck/output/pptx/template_template_pitch_long.pptx
@@ -3968,11 +3968,11 @@
               </a:defRPr>
             </a:pPr>
             <a:r>
-              <a:t>• src/template_template/introspection.py discovers infrastructure/ subpackages,</a:t>
+              <a:t>• src/template_template/core/introspection.py discovers infrastructure/</a:t>
             </a:r>
             <a:br/>
             <a:r>
-              <a:t>the pipeline.yaml stage DAG, and the public exemplar roster.</a:t>
+              <a:t>subpackages, the pipeline.yaml stage DAG, and the public exemplar roster.</a:t>
             </a:r>
           </a:p>
           <a:p>
@@ -6611,7 +6611,7 @@
                   <a:srgbClr val="B3131A"/>
                 </a:solidFill>
               </a:rPr>
-              <a:t>147 tests</a:t>
+              <a:t>153 tests</a:t>
             </a:r>
           </a:p>
         </p:txBody>
@@ -6644,7 +6644,7 @@
                   <a:srgbClr val="0A0A0A"/>
                 </a:solidFill>
               </a:rPr>
-              <a:t>97.66% coverage on template_template's own source — the same gate every exemplar in the repo must pass. No partial-credit reporting path exists.</a:t>
+              <a:t>97.07% coverage on template_template's own source — the same gate every exemplar in the repo must pass. No partial-credit reporting path exists.</a:t>
             </a:r>
           </a:p>
         </p:txBody>
@@ -6832,7 +6832,7 @@
                   <a:srgbClr val="B3131A"/>
                 </a:solidFill>
               </a:rPr>
-              <a:t>9 platforms</a:t>
+              <a:t>9 historical references</a:t>
             </a:r>
           </a:p>
         </p:txBody>
@@ -6865,7 +6865,7 @@
                   <a:srgbClr val="0A0A0A"/>
                 </a:solidFill>
               </a:rPr>
-              <a:t>Durable publication records already on file (concept DOI 10.5281/zenodo.20419007): Zenodo, GitHub, PyPI (sandbox), IPFS, Software Heritage, GitHub Pages, Netlify, Hugging Face, OSF. Licensed Apache-2.0.</a:t>
+              <a:t>Prior v1.0.9 references: Zenodo, GitHub, PyPI (sandbox), IPFS, Software Heritage, GitHub Pages, Netlify, Hugging Face, OSF. Intended v2.0.0 is unreleased. Licensed Apache-2.0.</a:t>
             </a:r>
           </a:p>
         </p:txBody>
@@ -7172,7 +7172,7 @@
                 </a:solidFill>
                 <a:hlinkClick r:id="rId2"/>
               </a:rPr>
-              <a:t>Source: projects/templates/template_pitch_deck/src/deck_tokens.py</a:t>
+              <a:t>Source: projects/templates/template_pitch_deck/src/template_pitch_deck/deck_tokens.py</a:t>
             </a:r>
           </a:p>
         </p:txBody>
@@ -7528,7 +7528,7 @@
               </a:defRPr>
             </a:pPr>
             <a:r>
-              <a:t>• projects/templates/ holds all 24 public exemplars: template_active_inference,</a:t>
+              <a:t>• projects/templates/ holds all 25 public exemplars: template_active_inference,</a:t>
             </a:r>
             <a:br/>
             <a:r>
@@ -7544,19 +7544,19 @@
             </a:r>
             <a:br/>
             <a:r>
-              <a:t>template_formal, template_gold_refinement, template_literature_meta_analysis,</a:t>
+              <a:t>template_experiment_tree, template_formal, template_gold_refinement,</a:t>
             </a:r>
             <a:br/>
             <a:r>
-              <a:t>template_madlib, template_methods_paper, template_newspaper,</a:t>
+              <a:t>template_literature_meta_analysis, template_madlib, template_methods_paper,</a:t>
             </a:r>
             <a:br/>
             <a:r>
-              <a:t>template_pitch_deck, template_pools_rules_tools, template_prose_project,</a:t>
+              <a:t>template_newspaper, template_pitch_deck, template_pools_rules_tools,</a:t>
             </a:r>
             <a:br/>
             <a:r>
-              <a:t>template_redacted_report, template_registered_report,</a:t>
+              <a:t>template_prose_project, template_redacted_report, template_registered_report,</a:t>
             </a:r>
             <a:br/>
             <a:r>
@@ -7814,7 +7814,7 @@
             </a:r>
             <a:br/>
             <a:r>
-              <a:t>add — the contract is uniform across all 24 projects, and the folder itself is the</a:t>
+              <a:t>add — the contract is uniform across all 25 projects, and the folder itself is the</a:t>
             </a:r>
             <a:br/>
             <a:r>
@@ -10261,7 +10261,7 @@
                 </a:solidFill>
                 <a:hlinkClick r:id="rId3"/>
               </a:rPr>
-              <a:t>Source: projects/templates/template_pitch_deck/src/token_resolution.py</a:t>
+              <a:t>Source: projects/templates/template_pitch_deck/src/template_pitch_deck/token_resolution.py</a:t>
             </a:r>
           </a:p>
         </p:txBody>
@@ -10538,7 +10538,7 @@
                 </a:solidFill>
                 <a:hlinkClick r:id="rId2"/>
               </a:rPr>
-              <a:t>Source: projects/templates/template_pitch_deck/src/diligence_audit.py</a:t>
+              <a:t>Source: projects/templates/template_pitch_deck/src/template_pitch_deck/diligence_audit.py</a:t>
             </a:r>
           </a:p>
         </p:txBody>
@@ -10992,7 +10992,7 @@
               </a:defRPr>
             </a:pPr>
             <a:r>
-              <a:t>• Every one of 24 public exemplars is measured independently, not summarized</a:t>
+              <a:t>• Every one of 25 public exemplars is measured independently, not summarized</a:t>
             </a:r>
             <a:br/>
             <a:r>
@@ -11019,7 +11019,7 @@
             </a:r>
             <a:br/>
             <a:r>
-              <a:t>docs/_generated/COUNTS.md factsheet this deck's own 97.66% figure comes</a:t>
+              <a:t>docs/_generated/COUNTS.md factsheet this deck's own 97.07% figure comes</a:t>
             </a:r>
             <a:br/>
             <a:r>
@@ -11392,8 +11392,8 @@
         </p:blipFill>
         <p:spPr>
           <a:xfrm>
-            <a:off x="2126158" y="914400"/>
-            <a:ext cx="4891682" cy="3415284"/>
+            <a:off x="2223992" y="914400"/>
+            <a:ext cx="4696015" cy="3415284"/>
           </a:xfrm>
           <a:prstGeom prst="rect">
             <a:avLst/>
@@ -11915,7 +11915,7 @@
                 </a:solidFill>
                 <a:hlinkClick r:id="rId2"/>
               </a:rPr>
-              <a:t>Source: projects/templates/template_pitch_deck/src/diligence_audit.py</a:t>
+              <a:t>Source: projects/templates/template_pitch_deck/src/template_pitch_deck/diligence_audit.py</a:t>
             </a:r>
           </a:p>
         </p:txBody>
@@ -12196,7 +12196,7 @@
                 </a:solidFill>
                 <a:hlinkClick r:id="rId2"/>
               </a:rPr>
-              <a:t>Source: projects/templates/template_pitch_deck/src/standalone_slides.py</a:t>
+              <a:t>Source: projects/templates/template_pitch_deck/src/template_pitch_deck/standalone_slides.py</a:t>
             </a:r>
           </a:p>
         </p:txBody>
@@ -12856,15 +12856,15 @@
               </a:defRPr>
             </a:pPr>
             <a:r>
-              <a:t>• 25 importable subpackages, 752 tracked Python files total under infrastructure/</a:t>
+              <a:t>• 28 importable subpackages, 1302 tracked Python files total under</a:t>
             </a:r>
             <a:br/>
             <a:r>
-              <a:t>— a real inventory anyone can `git ls-files` themselves, not a claimed</a:t>
+              <a:t>infrastructure/ — a real inventory anyone can `git ls-files` themselves, not a</a:t>
             </a:r>
             <a:br/>
             <a:r>
-              <a:t>abstraction.</a:t>
+              <a:t>claimed abstraction.</a:t>
             </a:r>
           </a:p>
           <a:p>
@@ -12883,11 +12883,11 @@
               </a:defRPr>
             </a:pPr>
             <a:r>
-              <a:t>• The largest single subpackage, core, holds 129 files — still a minority of the</a:t>
+              <a:t>• The largest single subpackage, reporting, holds 399 files — still a minority of</a:t>
             </a:r>
             <a:br/>
             <a:r>
-              <a:t>whole, not a monolith wearing a modular label.</a:t>
+              <a:t>the whole, not a monolith wearing a modular label.</a:t>
             </a:r>
           </a:p>
           <a:p>
@@ -12933,7 +12933,7 @@
               </a:defRPr>
             </a:pPr>
             <a:r>
-              <a:t>• The next chart narrows the total to importable subpackages, excluding 2</a:t>
+              <a:t>• The next chart narrows the total to importable subpackages, excluding 3</a:t>
             </a:r>
             <a:br/>
             <a:r>
@@ -12971,7 +12971,7 @@
                 </a:solidFill>
                 <a:hlinkClick r:id="rId2"/>
               </a:rPr>
-              <a:t>Source: projects/templates/template_pitch_deck/src/infra_facts.py</a:t>
+              <a:t>Source: projects/templates/template_pitch_deck/src/template_pitch_deck/infra_facts.py</a:t>
             </a:r>
           </a:p>
         </p:txBody>
@@ -13172,7 +13172,7 @@
                 </a:solidFill>
                 <a:hlinkClick r:id="rId3"/>
               </a:rPr>
-              <a:t>Source: projects/templates/template_pitch_deck/src/infra_facts.py</a:t>
+              <a:t>Source: projects/templates/template_pitch_deck/src/template_pitch_deck/infra_facts.py</a:t>
             </a:r>
           </a:p>
         </p:txBody>
@@ -16139,7 +16139,7 @@
               </a:defRPr>
             </a:pPr>
             <a:r>
-              <a:t>• One of 24 public exemplar templates in the same monorepo, each</a:t>
+              <a:t>• One of 25 public exemplar templates in the same monorepo, each</a:t>
             </a:r>
             <a:br/>
             <a:r>

</xml_diff>

<commit_message>
Refresh exemplar publications and native export diagnostics
</commit_message>
<xml_diff>
--- a/projects/templates/template_pitch_deck/output/pptx/template_template_pitch_long.pptx
+++ b/projects/templates/template_pitch_deck/output/pptx/template_template_pitch_long.pptx
@@ -6611,7 +6611,7 @@
                   <a:srgbClr val="B3131A"/>
                 </a:solidFill>
               </a:rPr>
-              <a:t>153 tests</a:t>
+              <a:t>154 tests</a:t>
             </a:r>
           </a:p>
         </p:txBody>
@@ -12856,7 +12856,7 @@
               </a:defRPr>
             </a:pPr>
             <a:r>
-              <a:t>• 28 importable subpackages, 1302 tracked Python files total under</a:t>
+              <a:t>• 28 importable subpackages, 1321 tracked Python files total under</a:t>
             </a:r>
             <a:br/>
             <a:r>
@@ -12883,7 +12883,7 @@
               </a:defRPr>
             </a:pPr>
             <a:r>
-              <a:t>• The largest single subpackage, reporting, holds 399 files — still a minority of</a:t>
+              <a:t>• The largest single subpackage, reporting, holds 406 files — still a minority of</a:t>
             </a:r>
             <a:br/>
             <a:r>

</xml_diff>

<commit_message>
Integrate reviewed 4.1 publication corrections
</commit_message>
<xml_diff>
--- a/projects/templates/template_pitch_deck/output/pptx/template_template_pitch_long.pptx
+++ b/projects/templates/template_pitch_deck/output/pptx/template_template_pitch_long.pptx
@@ -6611,7 +6611,7 @@
                   <a:srgbClr val="B3131A"/>
                 </a:solidFill>
               </a:rPr>
-              <a:t>154 tests</a:t>
+              <a:t>158 tests</a:t>
             </a:r>
           </a:p>
         </p:txBody>
@@ -6644,7 +6644,7 @@
                   <a:srgbClr val="0A0A0A"/>
                 </a:solidFill>
               </a:rPr>
-              <a:t>97.07% coverage on template_template's own source — the same gate every exemplar in the repo must pass. No partial-credit reporting path exists.</a:t>
+              <a:t>95.56% coverage on template_template's own source — the same gate every exemplar in the repo must pass. No partial-credit reporting path exists.</a:t>
             </a:r>
           </a:p>
         </p:txBody>
@@ -11019,7 +11019,7 @@
             </a:r>
             <a:br/>
             <a:r>
-              <a:t>docs/_generated/COUNTS.md factsheet this deck's own 97.07% figure comes</a:t>
+              <a:t>docs/_generated/COUNTS.md factsheet this deck's own 95.56% figure comes</a:t>
             </a:r>
             <a:br/>
             <a:r>
@@ -12856,7 +12856,7 @@
               </a:defRPr>
             </a:pPr>
             <a:r>
-              <a:t>• 28 importable subpackages, 1324 tracked Python files total under</a:t>
+              <a:t>• 28 importable subpackages, 1339 tracked Python files total under</a:t>
             </a:r>
             <a:br/>
             <a:r>
@@ -12883,7 +12883,7 @@
               </a:defRPr>
             </a:pPr>
             <a:r>
-              <a:t>• The largest single subpackage, reporting, holds 406 files — still a minority of</a:t>
+              <a:t>• The largest single subpackage, reporting, holds 409 files — still a minority of</a:t>
             </a:r>
             <a:br/>
             <a:r>

</xml_diff>

<commit_message>
fix: align exemplar figures, dashboards, and search scoring prose
</commit_message>
<xml_diff>
--- a/projects/templates/template_pitch_deck/output/pptx/template_template_pitch_long.pptx
+++ b/projects/templates/template_pitch_deck/output/pptx/template_template_pitch_long.pptx
@@ -6600,8 +6600,8 @@
           <a:noFill/>
         </p:spPr>
         <p:txBody>
-          <a:bodyPr wrap="none">
-            <a:spAutoFit/>
+          <a:bodyPr wrap="none" lIns="0" rIns="0" tIns="0" bIns="0">
+            <a:noAutofit/>
           </a:bodyPr>
           <a:lstStyle/>
           <a:p>
@@ -6610,6 +6610,7 @@
                 <a:solidFill>
                   <a:srgbClr val="B3131A"/>
                 </a:solidFill>
+                <a:latin typeface="Helvetica"/>
               </a:rPr>
               <a:t>158 tests</a:t>
             </a:r>
@@ -6821,16 +6822,17 @@
           <a:noFill/>
         </p:spPr>
         <p:txBody>
-          <a:bodyPr wrap="none">
-            <a:spAutoFit/>
+          <a:bodyPr wrap="none" lIns="0" rIns="0" tIns="0" bIns="0">
+            <a:noAutofit/>
           </a:bodyPr>
           <a:lstStyle/>
           <a:p>
             <a:r>
-              <a:rPr sz="6800" b="1">
+              <a:rPr sz="6000" b="1">
                 <a:solidFill>
                   <a:srgbClr val="B3131A"/>
                 </a:solidFill>
+                <a:latin typeface="Helvetica"/>
               </a:rPr>
               <a:t>9 historical references</a:t>
             </a:r>
@@ -12937,7 +12939,7 @@
             </a:r>
             <a:br/>
             <a:r>
-              <a:t>top-level file(s): infrastructure/__init__.py and mcp_server.py.</a:t>
+              <a:t>top-level Python file(s).</a:t>
             </a:r>
           </a:p>
         </p:txBody>

</xml_diff>

<commit_message>
Complete API retirement and regenerate public analyses
</commit_message>
<xml_diff>
--- a/projects/templates/template_pitch_deck/output/pptx/template_template_pitch_long.pptx
+++ b/projects/templates/template_pitch_deck/output/pptx/template_template_pitch_long.pptx
@@ -6645,7 +6645,7 @@
                   <a:srgbClr val="0A0A0A"/>
                 </a:solidFill>
               </a:rPr>
-              <a:t>95.56% coverage on template_template's own source — the same gate every exemplar in the repo must pass. No partial-credit reporting path exists.</a:t>
+              <a:t>95.57% coverage on template_template's own source — the same gate every exemplar in the repo must pass. No partial-credit reporting path exists.</a:t>
             </a:r>
           </a:p>
         </p:txBody>
@@ -11021,7 +11021,7 @@
             </a:r>
             <a:br/>
             <a:r>
-              <a:t>docs/_generated/COUNTS.md factsheet this deck's own 95.56% figure comes</a:t>
+              <a:t>docs/_generated/COUNTS.md factsheet this deck's own 95.57% figure comes</a:t>
             </a:r>
             <a:br/>
             <a:r>
@@ -12858,7 +12858,7 @@
               </a:defRPr>
             </a:pPr>
             <a:r>
-              <a:t>• 28 importable subpackages, 1339 tracked Python files total under</a:t>
+              <a:t>• 28 importable subpackages, 1351 tracked Python files total under</a:t>
             </a:r>
             <a:br/>
             <a:r>
@@ -12885,7 +12885,7 @@
               </a:defRPr>
             </a:pPr>
             <a:r>
-              <a:t>• The largest single subpackage, reporting, holds 409 files — still a minority of</a:t>
+              <a:t>• The largest single subpackage, reporting, holds 411 files — still a minority of</a:t>
             </a:r>
             <a:br/>
             <a:r>

</xml_diff>

<commit_message>
Refresh validated 4.4.1 public exemplar outputs
</commit_message>
<xml_diff>
--- a/projects/templates/template_pitch_deck/output/pptx/template_template_pitch_long.pptx
+++ b/projects/templates/template_pitch_deck/output/pptx/template_template_pitch_long.pptx
@@ -6612,7 +6612,7 @@
                 </a:solidFill>
                 <a:latin typeface="Helvetica"/>
               </a:rPr>
-              <a:t>158 tests</a:t>
+              <a:t>161 tests</a:t>
             </a:r>
           </a:p>
         </p:txBody>
@@ -6645,7 +6645,7 @@
                   <a:srgbClr val="0A0A0A"/>
                 </a:solidFill>
               </a:rPr>
-              <a:t>95.57% coverage on template_template's own source — the same gate every exemplar in the repo must pass. No partial-credit reporting path exists.</a:t>
+              <a:t>95.55% coverage on template_template's own source — the same gate every exemplar in the repo must pass. No partial-credit reporting path exists.</a:t>
             </a:r>
           </a:p>
         </p:txBody>
@@ -11021,7 +11021,7 @@
             </a:r>
             <a:br/>
             <a:r>
-              <a:t>docs/_generated/COUNTS.md factsheet this deck's own 95.57% figure comes</a:t>
+              <a:t>docs/_generated/COUNTS.md factsheet this deck's own 95.55% figure comes</a:t>
             </a:r>
             <a:br/>
             <a:r>

</xml_diff>